<commit_message>
update of the presentation
</commit_message>
<xml_diff>
--- a/booklets/seismic_final_presentation.pptx
+++ b/booklets/seismic_final_presentation.pptx
@@ -7787,7 +7787,7 @@
         </p:nvSpPr>
         <p:spPr>
           <a:xfrm>
-            <a:off x="2770632" y="3255264"/>
+            <a:off x="2610611" y="3096112"/>
             <a:ext cx="1645920" cy="822960"/>
           </a:xfrm>
           <a:prstGeom prst="roundRect">
@@ -7833,7 +7833,7 @@
         </p:nvSpPr>
         <p:spPr>
           <a:xfrm>
-            <a:off x="2953512" y="3511296"/>
+            <a:off x="2793491" y="3352144"/>
             <a:ext cx="1234440" cy="228600"/>
           </a:xfrm>
           <a:prstGeom prst="rect">
@@ -7865,7 +7865,7 @@
         </p:nvSpPr>
         <p:spPr>
           <a:xfrm>
-            <a:off x="965231" y="3253101"/>
+            <a:off x="805210" y="3093949"/>
             <a:ext cx="1463040" cy="804672"/>
           </a:xfrm>
           <a:prstGeom prst="roundRect">
@@ -7911,7 +7911,7 @@
         </p:nvSpPr>
         <p:spPr>
           <a:xfrm>
-            <a:off x="1102391" y="3509132"/>
+            <a:off x="942370" y="3349980"/>
             <a:ext cx="1188720" cy="274320"/>
           </a:xfrm>
           <a:prstGeom prst="rect">
@@ -7943,7 +7943,7 @@
         </p:nvSpPr>
         <p:spPr>
           <a:xfrm>
-            <a:off x="4472742" y="3519653"/>
+            <a:off x="4312721" y="3360501"/>
             <a:ext cx="228600" cy="320040"/>
           </a:xfrm>
           <a:prstGeom prst="chevron">
@@ -7987,7 +7987,7 @@
         </p:nvSpPr>
         <p:spPr>
           <a:xfrm>
-            <a:off x="2879131" y="2106824"/>
+            <a:off x="2719110" y="1947672"/>
             <a:ext cx="1463040" cy="804672"/>
           </a:xfrm>
           <a:prstGeom prst="roundRect">
@@ -8033,7 +8033,7 @@
         </p:nvSpPr>
         <p:spPr>
           <a:xfrm>
-            <a:off x="3016291" y="2339996"/>
+            <a:off x="2856270" y="2180844"/>
             <a:ext cx="1188720" cy="274320"/>
           </a:xfrm>
           <a:prstGeom prst="rect">
@@ -8065,7 +8065,7 @@
         </p:nvSpPr>
         <p:spPr>
           <a:xfrm rot="16200000">
-            <a:off x="3456432" y="2919836"/>
+            <a:off x="3296411" y="2760684"/>
             <a:ext cx="228600" cy="320040"/>
           </a:xfrm>
           <a:prstGeom prst="chevron">
@@ -8109,7 +8109,7 @@
         </p:nvSpPr>
         <p:spPr>
           <a:xfrm>
-            <a:off x="4792981" y="3310128"/>
+            <a:off x="4632960" y="3150976"/>
             <a:ext cx="1463040" cy="804672"/>
           </a:xfrm>
           <a:prstGeom prst="roundRect">
@@ -8155,7 +8155,7 @@
         </p:nvSpPr>
         <p:spPr>
           <a:xfrm>
-            <a:off x="4930141" y="3588152"/>
+            <a:off x="4770120" y="3429000"/>
             <a:ext cx="1188720" cy="274320"/>
           </a:xfrm>
           <a:prstGeom prst="rect">
@@ -8187,7 +8187,7 @@
         </p:nvSpPr>
         <p:spPr>
           <a:xfrm rot="10800000">
-            <a:off x="2485152" y="3519652"/>
+            <a:off x="2325131" y="3360500"/>
             <a:ext cx="228600" cy="320040"/>
           </a:xfrm>
           <a:prstGeom prst="chevron">
@@ -8231,7 +8231,7 @@
         </p:nvSpPr>
         <p:spPr>
           <a:xfrm>
-            <a:off x="2147611" y="4446018"/>
+            <a:off x="1987590" y="4286866"/>
             <a:ext cx="1463040" cy="804672"/>
           </a:xfrm>
           <a:prstGeom prst="roundRect">
@@ -8277,7 +8277,7 @@
         </p:nvSpPr>
         <p:spPr>
           <a:xfrm>
-            <a:off x="2353073" y="4686547"/>
+            <a:off x="2193052" y="4527395"/>
             <a:ext cx="1038939" cy="338554"/>
           </a:xfrm>
           <a:prstGeom prst="rect">
@@ -8309,7 +8309,7 @@
         </p:nvSpPr>
         <p:spPr>
           <a:xfrm rot="5400000">
-            <a:off x="4053842" y="4093612"/>
+            <a:off x="3893821" y="3934460"/>
             <a:ext cx="228600" cy="320040"/>
           </a:xfrm>
           <a:prstGeom prst="chevron">
@@ -8353,7 +8353,7 @@
         </p:nvSpPr>
         <p:spPr>
           <a:xfrm>
-            <a:off x="3741222" y="4455850"/>
+            <a:off x="3581201" y="4296698"/>
             <a:ext cx="1463040" cy="794840"/>
           </a:xfrm>
           <a:prstGeom prst="roundRect">
@@ -8399,7 +8399,7 @@
         </p:nvSpPr>
         <p:spPr>
           <a:xfrm>
-            <a:off x="3953273" y="4707457"/>
+            <a:off x="3793252" y="4548305"/>
             <a:ext cx="1038939" cy="338554"/>
           </a:xfrm>
           <a:prstGeom prst="rect">
@@ -8431,7 +8431,7 @@
         </p:nvSpPr>
         <p:spPr>
           <a:xfrm rot="5400000">
-            <a:off x="2999232" y="4087368"/>
+            <a:off x="2839211" y="3928216"/>
             <a:ext cx="228600" cy="320040"/>
           </a:xfrm>
           <a:prstGeom prst="chevron">
@@ -8475,8 +8475,8 @@
         </p:nvSpPr>
         <p:spPr>
           <a:xfrm>
-            <a:off x="6987740" y="1737360"/>
-            <a:ext cx="3939339" cy="3185487"/>
+            <a:off x="6472429" y="2398138"/>
+            <a:ext cx="4575711" cy="2564805"/>
           </a:xfrm>
           <a:prstGeom prst="rect">
             <a:avLst/>
@@ -8521,7 +8521,61 @@
                 </a:solidFill>
                 <a:latin typeface="Aptos"/>
               </a:rPr>
-              <a:t>Each replica analyzes sensors independently and can detect the same event without cross-node coordination.</a:t>
+              <a:t>Each replica analyzes </a:t>
+            </a:r>
+            <a:r>
+              <a:rPr lang="it-IT" sz="1600" dirty="0" err="1">
+                <a:solidFill>
+                  <a:srgbClr val="1D1D1D"/>
+                </a:solidFill>
+                <a:latin typeface="Aptos"/>
+              </a:rPr>
+              <a:t>all</a:t>
+            </a:r>
+            <a:r>
+              <a:rPr lang="it-IT" sz="1600" dirty="0">
+                <a:solidFill>
+                  <a:srgbClr val="1D1D1D"/>
+                </a:solidFill>
+                <a:latin typeface="Aptos"/>
+              </a:rPr>
+              <a:t> </a:t>
+            </a:r>
+            <a:r>
+              <a:rPr sz="1600" dirty="0">
+                <a:solidFill>
+                  <a:srgbClr val="1D1D1D"/>
+                </a:solidFill>
+                <a:latin typeface="Aptos"/>
+              </a:rPr>
+              <a:t>sensors independently and </a:t>
+            </a:r>
+            <a:r>
+              <a:rPr lang="it-IT" sz="1600" dirty="0" err="1">
+                <a:solidFill>
+                  <a:srgbClr val="1D1D1D"/>
+                </a:solidFill>
+                <a:latin typeface="Aptos"/>
+              </a:rPr>
+              <a:t>will</a:t>
+            </a:r>
+            <a:r>
+              <a:rPr sz="1600" dirty="0">
+                <a:solidFill>
+                  <a:srgbClr val="1D1D1D"/>
+                </a:solidFill>
+                <a:latin typeface="Aptos"/>
+              </a:rPr>
+              <a:t> detect the same event</a:t>
+            </a:r>
+            <a:r>
+              <a:rPr lang="it-IT" sz="1600" dirty="0">
+                <a:solidFill>
+                  <a:srgbClr val="1D1D1D"/>
+                </a:solidFill>
+                <a:latin typeface="Aptos"/>
+              </a:rPr>
+              <a:t>s. </a:t>
             </a:r>
           </a:p>
           <a:p>
@@ -8539,17 +8593,107 @@
                 </a:solidFill>
                 <a:latin typeface="Aptos"/>
               </a:rPr>
-              <a:t>Replica failures reduce throughput, not platform value: healthy nodes keep forwarding detections to the gateway.</a:t>
-            </a:r>
-          </a:p>
-          <a:p>
-            <a:pPr marL="285750" indent="-285750">
-              <a:spcAft>
-                <a:spcPts val="1000"/>
-              </a:spcAft>
-              <a:buFont typeface="Arial" panose="020B0604020202020204" pitchFamily="34" charset="0"/>
-              <a:buChar char="•"/>
-            </a:pPr>
+              <a:t>Replica failures</a:t>
+            </a:r>
+            <a:r>
+              <a:rPr lang="it-IT" sz="1600" dirty="0">
+                <a:solidFill>
+                  <a:srgbClr val="1D1D1D"/>
+                </a:solidFill>
+                <a:latin typeface="Aptos"/>
+              </a:rPr>
+              <a:t> </a:t>
+            </a:r>
+            <a:r>
+              <a:rPr lang="it-IT" sz="1600" dirty="0" err="1">
+                <a:solidFill>
+                  <a:srgbClr val="1D1D1D"/>
+                </a:solidFill>
+                <a:latin typeface="Aptos"/>
+              </a:rPr>
+              <a:t>don’t</a:t>
+            </a:r>
+            <a:r>
+              <a:rPr lang="it-IT" sz="1600" dirty="0">
+                <a:solidFill>
+                  <a:srgbClr val="1D1D1D"/>
+                </a:solidFill>
+                <a:latin typeface="Aptos"/>
+              </a:rPr>
+              <a:t> reduce throughput of the system </a:t>
+            </a:r>
+            <a:r>
+              <a:rPr lang="it-IT" sz="1600" dirty="0" err="1">
+                <a:solidFill>
+                  <a:srgbClr val="1D1D1D"/>
+                </a:solidFill>
+                <a:latin typeface="Aptos"/>
+              </a:rPr>
+              <a:t>until</a:t>
+            </a:r>
+            <a:r>
+              <a:rPr lang="it-IT" sz="1600" dirty="0">
+                <a:solidFill>
+                  <a:srgbClr val="1D1D1D"/>
+                </a:solidFill>
+                <a:latin typeface="Aptos"/>
+              </a:rPr>
+              <a:t> </a:t>
+            </a:r>
+            <a:r>
+              <a:rPr lang="it-IT" sz="1600" dirty="0" err="1">
+                <a:solidFill>
+                  <a:srgbClr val="1D1D1D"/>
+                </a:solidFill>
+                <a:latin typeface="Aptos"/>
+              </a:rPr>
+              <a:t>there</a:t>
+            </a:r>
+            <a:r>
+              <a:rPr lang="it-IT" sz="1600" dirty="0">
+                <a:solidFill>
+                  <a:srgbClr val="1D1D1D"/>
+                </a:solidFill>
+                <a:latin typeface="Aptos"/>
+              </a:rPr>
+              <a:t> </a:t>
+            </a:r>
+            <a:r>
+              <a:rPr lang="it-IT" sz="1600" dirty="0" err="1">
+                <a:solidFill>
+                  <a:srgbClr val="1D1D1D"/>
+                </a:solidFill>
+                <a:latin typeface="Aptos"/>
+              </a:rPr>
+              <a:t>is</a:t>
+            </a:r>
+            <a:r>
+              <a:rPr lang="it-IT" sz="1600" dirty="0">
+                <a:solidFill>
+                  <a:srgbClr val="1D1D1D"/>
+                </a:solidFill>
+                <a:latin typeface="Aptos"/>
+              </a:rPr>
+              <a:t> no replica </a:t>
+            </a:r>
+            <a:r>
+              <a:rPr lang="it-IT" sz="1600" dirty="0" err="1">
+                <a:solidFill>
+                  <a:srgbClr val="1D1D1D"/>
+                </a:solidFill>
+                <a:latin typeface="Aptos"/>
+              </a:rPr>
+              <a:t>alive</a:t>
+            </a:r>
+            <a:r>
+              <a:rPr lang="it-IT" sz="1600" dirty="0">
+                <a:solidFill>
+                  <a:srgbClr val="1D1D1D"/>
+                </a:solidFill>
+                <a:latin typeface="Aptos"/>
+              </a:rPr>
+              <a:t>: </a:t>
+            </a:r>
             <a:r>
               <a:rPr sz="1600" dirty="0">
                 <a:solidFill>
@@ -8557,8 +8701,23 @@
                 </a:solidFill>
                 <a:latin typeface="Aptos"/>
               </a:rPr>
-              <a:t>Graceful shutdown remains available through the simulator control SSE stream.</a:t>
-            </a:r>
+              <a:t>healthy nodes keep forwarding detections to the gateway</a:t>
+            </a:r>
+            <a:r>
+              <a:rPr lang="it-IT" sz="1600" dirty="0">
+                <a:solidFill>
+                  <a:srgbClr val="1D1D1D"/>
+                </a:solidFill>
+                <a:latin typeface="Aptos"/>
+              </a:rPr>
+              <a:t>.</a:t>
+            </a:r>
+            <a:endParaRPr sz="1600" dirty="0">
+              <a:solidFill>
+                <a:srgbClr val="1D1D1D"/>
+              </a:solidFill>
+              <a:latin typeface="Aptos"/>
+            </a:endParaRPr>
           </a:p>
         </p:txBody>
       </p:sp>
@@ -9963,8 +10122,8 @@
         </p:nvSpPr>
         <p:spPr>
           <a:xfrm>
-            <a:off x="868680" y="1691640"/>
-            <a:ext cx="5074920" cy="3400931"/>
+            <a:off x="640080" y="1996778"/>
+            <a:ext cx="5074920" cy="3272691"/>
           </a:xfrm>
           <a:prstGeom prst="rect">
             <a:avLst/>
@@ -9985,13 +10144,184 @@
               <a:buChar char="•"/>
             </a:pPr>
             <a:r>
-              <a:rPr sz="1900" dirty="0">
-                <a:solidFill>
-                  <a:srgbClr val="1D1D1D"/>
-                </a:solidFill>
-                <a:latin typeface="Aptos"/>
-              </a:rPr>
-              <a:t>Replicas call POST /api/sensors once per sensor and POST /api/events for every detection.</a:t>
+              <a:rPr lang="it-IT" sz="1900" dirty="0" err="1">
+                <a:solidFill>
+                  <a:srgbClr val="1D1D1D"/>
+                </a:solidFill>
+                <a:latin typeface="Aptos"/>
+              </a:rPr>
+              <a:t>Replicas</a:t>
+            </a:r>
+            <a:r>
+              <a:rPr lang="it-IT" sz="1900" dirty="0">
+                <a:solidFill>
+                  <a:srgbClr val="1D1D1D"/>
+                </a:solidFill>
+                <a:latin typeface="Aptos"/>
+              </a:rPr>
+              <a:t> </a:t>
+            </a:r>
+            <a:r>
+              <a:rPr lang="it-IT" sz="1900" dirty="0" err="1">
+                <a:solidFill>
+                  <a:srgbClr val="1D1D1D"/>
+                </a:solidFill>
+                <a:latin typeface="Aptos"/>
+              </a:rPr>
+              <a:t>register</a:t>
+            </a:r>
+            <a:r>
+              <a:rPr lang="it-IT" sz="1900" dirty="0">
+                <a:solidFill>
+                  <a:srgbClr val="1D1D1D"/>
+                </a:solidFill>
+                <a:latin typeface="Aptos"/>
+              </a:rPr>
+              <a:t> </a:t>
+            </a:r>
+            <a:r>
+              <a:rPr lang="it-IT" sz="1900" dirty="0" err="1">
+                <a:solidFill>
+                  <a:srgbClr val="1D1D1D"/>
+                </a:solidFill>
+                <a:latin typeface="Aptos"/>
+              </a:rPr>
+              <a:t>each</a:t>
+            </a:r>
+            <a:r>
+              <a:rPr lang="it-IT" sz="1900" dirty="0">
+                <a:solidFill>
+                  <a:srgbClr val="1D1D1D"/>
+                </a:solidFill>
+                <a:latin typeface="Aptos"/>
+              </a:rPr>
+              <a:t> </a:t>
+            </a:r>
+            <a:r>
+              <a:rPr lang="it-IT" sz="1900" dirty="0" err="1">
+                <a:solidFill>
+                  <a:srgbClr val="1D1D1D"/>
+                </a:solidFill>
+                <a:latin typeface="Aptos"/>
+              </a:rPr>
+              <a:t>sensor</a:t>
+            </a:r>
+            <a:r>
+              <a:rPr lang="it-IT" sz="1900" dirty="0">
+                <a:solidFill>
+                  <a:srgbClr val="1D1D1D"/>
+                </a:solidFill>
+                <a:latin typeface="Aptos"/>
+              </a:rPr>
+              <a:t> once </a:t>
+            </a:r>
+            <a:r>
+              <a:rPr lang="it-IT" sz="1900" dirty="0" err="1">
+                <a:solidFill>
+                  <a:srgbClr val="1D1D1D"/>
+                </a:solidFill>
+                <a:latin typeface="Aptos"/>
+              </a:rPr>
+              <a:t>through</a:t>
+            </a:r>
+            <a:r>
+              <a:rPr lang="it-IT" sz="1900" dirty="0">
+                <a:solidFill>
+                  <a:srgbClr val="1D1D1D"/>
+                </a:solidFill>
+                <a:latin typeface="Aptos"/>
+              </a:rPr>
+              <a:t> POST /api/</a:t>
+            </a:r>
+            <a:r>
+              <a:rPr lang="it-IT" sz="1900" dirty="0" err="1">
+                <a:solidFill>
+                  <a:srgbClr val="1D1D1D"/>
+                </a:solidFill>
+                <a:latin typeface="Aptos"/>
+              </a:rPr>
+              <a:t>sensors</a:t>
+            </a:r>
+            <a:r>
+              <a:rPr lang="it-IT" sz="1900" dirty="0">
+                <a:solidFill>
+                  <a:srgbClr val="1D1D1D"/>
+                </a:solidFill>
+                <a:latin typeface="Aptos"/>
+              </a:rPr>
+              <a:t> and </a:t>
+            </a:r>
+            <a:r>
+              <a:rPr lang="it-IT" sz="1900" dirty="0" err="1">
+                <a:solidFill>
+                  <a:srgbClr val="1D1D1D"/>
+                </a:solidFill>
+                <a:latin typeface="Aptos"/>
+              </a:rPr>
+              <a:t>submit</a:t>
+            </a:r>
+            <a:r>
+              <a:rPr lang="it-IT" sz="1900" dirty="0">
+                <a:solidFill>
+                  <a:srgbClr val="1D1D1D"/>
+                </a:solidFill>
+                <a:latin typeface="Aptos"/>
+              </a:rPr>
+              <a:t> </a:t>
+            </a:r>
+            <a:r>
+              <a:rPr lang="it-IT" sz="1900" dirty="0" err="1">
+                <a:solidFill>
+                  <a:srgbClr val="1D1D1D"/>
+                </a:solidFill>
+                <a:latin typeface="Aptos"/>
+              </a:rPr>
+              <a:t>every</a:t>
+            </a:r>
+            <a:r>
+              <a:rPr lang="it-IT" sz="1900" dirty="0">
+                <a:solidFill>
+                  <a:srgbClr val="1D1D1D"/>
+                </a:solidFill>
+                <a:latin typeface="Aptos"/>
+              </a:rPr>
+              <a:t> </a:t>
+            </a:r>
+            <a:r>
+              <a:rPr lang="it-IT" sz="1900" dirty="0" err="1">
+                <a:solidFill>
+                  <a:srgbClr val="1D1D1D"/>
+                </a:solidFill>
+                <a:latin typeface="Aptos"/>
+              </a:rPr>
+              <a:t>detected</a:t>
+            </a:r>
+            <a:r>
+              <a:rPr lang="it-IT" sz="1900" dirty="0">
+                <a:solidFill>
+                  <a:srgbClr val="1D1D1D"/>
+                </a:solidFill>
+                <a:latin typeface="Aptos"/>
+              </a:rPr>
+              <a:t> event </a:t>
+            </a:r>
+            <a:r>
+              <a:rPr lang="it-IT" sz="1900" dirty="0" err="1">
+                <a:solidFill>
+                  <a:srgbClr val="1D1D1D"/>
+                </a:solidFill>
+                <a:latin typeface="Aptos"/>
+              </a:rPr>
+              <a:t>through</a:t>
+            </a:r>
+            <a:r>
+              <a:rPr lang="it-IT" sz="1900" dirty="0">
+                <a:solidFill>
+                  <a:srgbClr val="1D1D1D"/>
+                </a:solidFill>
+                <a:latin typeface="Aptos"/>
+              </a:rPr>
+              <a:t> POST /api/events.</a:t>
             </a:r>
           </a:p>
           <a:p>
@@ -10003,13 +10333,274 @@
               <a:buChar char="•"/>
             </a:pPr>
             <a:r>
-              <a:rPr sz="1900" dirty="0">
-                <a:solidFill>
-                  <a:srgbClr val="1D1D1D"/>
-                </a:solidFill>
-                <a:latin typeface="Aptos"/>
-              </a:rPr>
-              <a:t>The gateway upserts sensor metadata, deduplicates repeated detections, persists confirmed events, and broadcasts only consolidated live updates.</a:t>
+              <a:rPr lang="it-IT" sz="1900" dirty="0" err="1">
+                <a:solidFill>
+                  <a:srgbClr val="1D1D1D"/>
+                </a:solidFill>
+                <a:latin typeface="Aptos"/>
+              </a:rPr>
+              <a:t>It</a:t>
+            </a:r>
+            <a:r>
+              <a:rPr lang="it-IT" sz="1900" dirty="0">
+                <a:solidFill>
+                  <a:srgbClr val="1D1D1D"/>
+                </a:solidFill>
+                <a:latin typeface="Aptos"/>
+              </a:rPr>
+              <a:t> </a:t>
+            </a:r>
+            <a:r>
+              <a:rPr lang="it-IT" sz="1900" dirty="0" err="1">
+                <a:solidFill>
+                  <a:srgbClr val="1D1D1D"/>
+                </a:solidFill>
+                <a:latin typeface="Aptos"/>
+              </a:rPr>
+              <a:t>receives</a:t>
+            </a:r>
+            <a:r>
+              <a:rPr lang="it-IT" sz="1900" dirty="0">
+                <a:solidFill>
+                  <a:srgbClr val="1D1D1D"/>
+                </a:solidFill>
+                <a:latin typeface="Aptos"/>
+              </a:rPr>
+              <a:t> </a:t>
+            </a:r>
+            <a:r>
+              <a:rPr lang="it-IT" sz="1900" dirty="0" err="1">
+                <a:solidFill>
+                  <a:srgbClr val="1D1D1D"/>
+                </a:solidFill>
+                <a:latin typeface="Aptos"/>
+              </a:rPr>
+              <a:t>detections</a:t>
+            </a:r>
+            <a:r>
+              <a:rPr lang="it-IT" sz="1900" dirty="0">
+                <a:solidFill>
+                  <a:srgbClr val="1D1D1D"/>
+                </a:solidFill>
+                <a:latin typeface="Aptos"/>
+              </a:rPr>
+              <a:t> from </a:t>
+            </a:r>
+            <a:r>
+              <a:rPr lang="it-IT" sz="1900" dirty="0" err="1">
+                <a:solidFill>
+                  <a:srgbClr val="1D1D1D"/>
+                </a:solidFill>
+                <a:latin typeface="Aptos"/>
+              </a:rPr>
+              <a:t>all</a:t>
+            </a:r>
+            <a:r>
+              <a:rPr lang="it-IT" sz="1900" dirty="0">
+                <a:solidFill>
+                  <a:srgbClr val="1D1D1D"/>
+                </a:solidFill>
+                <a:latin typeface="Aptos"/>
+              </a:rPr>
+              <a:t> </a:t>
+            </a:r>
+            <a:r>
+              <a:rPr lang="it-IT" sz="1900" dirty="0" err="1">
+                <a:solidFill>
+                  <a:srgbClr val="1D1D1D"/>
+                </a:solidFill>
+                <a:latin typeface="Aptos"/>
+              </a:rPr>
+              <a:t>replicas</a:t>
+            </a:r>
+            <a:r>
+              <a:rPr lang="it-IT" sz="1900" dirty="0">
+                <a:solidFill>
+                  <a:srgbClr val="1D1D1D"/>
+                </a:solidFill>
+                <a:latin typeface="Aptos"/>
+              </a:rPr>
+              <a:t> and </a:t>
+            </a:r>
+            <a:r>
+              <a:rPr lang="it-IT" sz="1900" dirty="0" err="1">
+                <a:solidFill>
+                  <a:srgbClr val="1D1D1D"/>
+                </a:solidFill>
+                <a:latin typeface="Aptos"/>
+              </a:rPr>
+              <a:t>applies</a:t>
+            </a:r>
+            <a:r>
+              <a:rPr lang="it-IT" sz="1900" dirty="0">
+                <a:solidFill>
+                  <a:srgbClr val="1D1D1D"/>
+                </a:solidFill>
+                <a:latin typeface="Aptos"/>
+              </a:rPr>
+              <a:t> </a:t>
+            </a:r>
+            <a:r>
+              <a:rPr lang="it-IT" sz="1900" dirty="0" err="1">
+                <a:solidFill>
+                  <a:srgbClr val="1D1D1D"/>
+                </a:solidFill>
+                <a:latin typeface="Aptos"/>
+              </a:rPr>
+              <a:t>deduplication</a:t>
+            </a:r>
+            <a:r>
+              <a:rPr lang="it-IT" sz="1900" dirty="0">
+                <a:solidFill>
+                  <a:srgbClr val="1D1D1D"/>
+                </a:solidFill>
+                <a:latin typeface="Aptos"/>
+              </a:rPr>
+              <a:t> so </a:t>
+            </a:r>
+            <a:r>
+              <a:rPr lang="it-IT" sz="1900" dirty="0" err="1">
+                <a:solidFill>
+                  <a:srgbClr val="1D1D1D"/>
+                </a:solidFill>
+                <a:latin typeface="Aptos"/>
+              </a:rPr>
+              <a:t>that</a:t>
+            </a:r>
+            <a:r>
+              <a:rPr lang="it-IT" sz="1900" dirty="0">
+                <a:solidFill>
+                  <a:srgbClr val="1D1D1D"/>
+                </a:solidFill>
+                <a:latin typeface="Aptos"/>
+              </a:rPr>
+              <a:t> </a:t>
+            </a:r>
+            <a:r>
+              <a:rPr lang="it-IT" sz="1900" dirty="0" err="1">
+                <a:solidFill>
+                  <a:srgbClr val="1D1D1D"/>
+                </a:solidFill>
+                <a:latin typeface="Aptos"/>
+              </a:rPr>
+              <a:t>repeated</a:t>
+            </a:r>
+            <a:r>
+              <a:rPr lang="it-IT" sz="1900" dirty="0">
+                <a:solidFill>
+                  <a:srgbClr val="1D1D1D"/>
+                </a:solidFill>
+                <a:latin typeface="Aptos"/>
+              </a:rPr>
+              <a:t> </a:t>
+            </a:r>
+            <a:r>
+              <a:rPr lang="it-IT" sz="1900" dirty="0" err="1">
+                <a:solidFill>
+                  <a:srgbClr val="1D1D1D"/>
+                </a:solidFill>
+                <a:latin typeface="Aptos"/>
+              </a:rPr>
+              <a:t>submissions</a:t>
+            </a:r>
+            <a:r>
+              <a:rPr lang="it-IT" sz="1900" dirty="0">
+                <a:solidFill>
+                  <a:srgbClr val="1D1D1D"/>
+                </a:solidFill>
+                <a:latin typeface="Aptos"/>
+              </a:rPr>
+              <a:t> from </a:t>
+            </a:r>
+            <a:r>
+              <a:rPr lang="it-IT" sz="1900" dirty="0" err="1">
+                <a:solidFill>
+                  <a:srgbClr val="1D1D1D"/>
+                </a:solidFill>
+                <a:latin typeface="Aptos"/>
+              </a:rPr>
+              <a:t>different</a:t>
+            </a:r>
+            <a:r>
+              <a:rPr lang="it-IT" sz="1900" dirty="0">
+                <a:solidFill>
+                  <a:srgbClr val="1D1D1D"/>
+                </a:solidFill>
+                <a:latin typeface="Aptos"/>
+              </a:rPr>
+              <a:t> </a:t>
+            </a:r>
+            <a:r>
+              <a:rPr lang="it-IT" sz="1900" dirty="0" err="1">
+                <a:solidFill>
+                  <a:srgbClr val="1D1D1D"/>
+                </a:solidFill>
+                <a:latin typeface="Aptos"/>
+              </a:rPr>
+              <a:t>replicas</a:t>
+            </a:r>
+            <a:r>
+              <a:rPr lang="it-IT" sz="1900" dirty="0">
+                <a:solidFill>
+                  <a:srgbClr val="1D1D1D"/>
+                </a:solidFill>
+                <a:latin typeface="Aptos"/>
+              </a:rPr>
+              <a:t> of the </a:t>
+            </a:r>
+            <a:r>
+              <a:rPr lang="it-IT" sz="1900" dirty="0" err="1">
+                <a:solidFill>
+                  <a:srgbClr val="1D1D1D"/>
+                </a:solidFill>
+                <a:latin typeface="Aptos"/>
+              </a:rPr>
+              <a:t>same</a:t>
+            </a:r>
+            <a:r>
+              <a:rPr lang="it-IT" sz="1900" dirty="0">
+                <a:solidFill>
+                  <a:srgbClr val="1D1D1D"/>
+                </a:solidFill>
+                <a:latin typeface="Aptos"/>
+              </a:rPr>
+              <a:t> event are </a:t>
+            </a:r>
+            <a:r>
+              <a:rPr lang="it-IT" sz="1900" dirty="0" err="1">
+                <a:solidFill>
+                  <a:srgbClr val="1D1D1D"/>
+                </a:solidFill>
+                <a:latin typeface="Aptos"/>
+              </a:rPr>
+              <a:t>accepted</a:t>
+            </a:r>
+            <a:r>
+              <a:rPr lang="it-IT" sz="1900" dirty="0">
+                <a:solidFill>
+                  <a:srgbClr val="1D1D1D"/>
+                </a:solidFill>
+                <a:latin typeface="Aptos"/>
+              </a:rPr>
+              <a:t> </a:t>
+            </a:r>
+            <a:r>
+              <a:rPr lang="it-IT" sz="1900" dirty="0" err="1">
+                <a:solidFill>
+                  <a:srgbClr val="1D1D1D"/>
+                </a:solidFill>
+                <a:latin typeface="Aptos"/>
+              </a:rPr>
+              <a:t>only</a:t>
+            </a:r>
+            <a:r>
+              <a:rPr lang="it-IT" sz="1900" dirty="0">
+                <a:solidFill>
+                  <a:srgbClr val="1D1D1D"/>
+                </a:solidFill>
+                <a:latin typeface="Aptos"/>
+              </a:rPr>
+              <a:t> once.</a:t>
             </a:r>
           </a:p>
           <a:p>
@@ -10021,13 +10612,157 @@
               <a:buChar char="•"/>
             </a:pPr>
             <a:r>
-              <a:rPr sz="1900" dirty="0">
-                <a:solidFill>
-                  <a:srgbClr val="1D1D1D"/>
-                </a:solidFill>
-                <a:latin typeface="Aptos"/>
-              </a:rPr>
-              <a:t>The SQL schema stays unchanged: sensors stores static metadata, events stores duplicate-safe history.</a:t>
+              <a:rPr lang="it-IT" sz="1900" dirty="0">
+                <a:solidFill>
+                  <a:srgbClr val="1D1D1D"/>
+                </a:solidFill>
+                <a:latin typeface="Aptos"/>
+              </a:rPr>
+              <a:t>The gateway </a:t>
+            </a:r>
+            <a:r>
+              <a:rPr lang="it-IT" sz="1900" dirty="0" err="1">
+                <a:solidFill>
+                  <a:srgbClr val="1D1D1D"/>
+                </a:solidFill>
+                <a:latin typeface="Aptos"/>
+              </a:rPr>
+              <a:t>then</a:t>
+            </a:r>
+            <a:r>
+              <a:rPr lang="it-IT" sz="1900" dirty="0">
+                <a:solidFill>
+                  <a:srgbClr val="1D1D1D"/>
+                </a:solidFill>
+                <a:latin typeface="Aptos"/>
+              </a:rPr>
+              <a:t> </a:t>
+            </a:r>
+            <a:r>
+              <a:rPr lang="it-IT" sz="1900" dirty="0" err="1">
+                <a:solidFill>
+                  <a:srgbClr val="1D1D1D"/>
+                </a:solidFill>
+                <a:latin typeface="Aptos"/>
+              </a:rPr>
+              <a:t>persists</a:t>
+            </a:r>
+            <a:r>
+              <a:rPr lang="it-IT" sz="1900" dirty="0">
+                <a:solidFill>
+                  <a:srgbClr val="1D1D1D"/>
+                </a:solidFill>
+                <a:latin typeface="Aptos"/>
+              </a:rPr>
+              <a:t> the </a:t>
+            </a:r>
+            <a:r>
+              <a:rPr lang="it-IT" sz="1900" dirty="0" err="1">
+                <a:solidFill>
+                  <a:srgbClr val="1D1D1D"/>
+                </a:solidFill>
+                <a:latin typeface="Aptos"/>
+              </a:rPr>
+              <a:t>confirmed</a:t>
+            </a:r>
+            <a:r>
+              <a:rPr lang="it-IT" sz="1900" dirty="0">
+                <a:solidFill>
+                  <a:srgbClr val="1D1D1D"/>
+                </a:solidFill>
+                <a:latin typeface="Aptos"/>
+              </a:rPr>
+              <a:t> event to </a:t>
+            </a:r>
+            <a:r>
+              <a:rPr lang="it-IT" sz="1900" dirty="0" err="1">
+                <a:solidFill>
+                  <a:srgbClr val="1D1D1D"/>
+                </a:solidFill>
+                <a:latin typeface="Aptos"/>
+              </a:rPr>
+              <a:t>PostgreSQL</a:t>
+            </a:r>
+            <a:r>
+              <a:rPr lang="it-IT" sz="1900" dirty="0">
+                <a:solidFill>
+                  <a:srgbClr val="1D1D1D"/>
+                </a:solidFill>
+                <a:latin typeface="Aptos"/>
+              </a:rPr>
+              <a:t> and </a:t>
+            </a:r>
+            <a:r>
+              <a:rPr lang="it-IT" sz="1900" dirty="0" err="1">
+                <a:solidFill>
+                  <a:srgbClr val="1D1D1D"/>
+                </a:solidFill>
+                <a:latin typeface="Aptos"/>
+              </a:rPr>
+              <a:t>broadcasts</a:t>
+            </a:r>
+            <a:r>
+              <a:rPr lang="it-IT" sz="1900" dirty="0">
+                <a:solidFill>
+                  <a:srgbClr val="1D1D1D"/>
+                </a:solidFill>
+                <a:latin typeface="Aptos"/>
+              </a:rPr>
+              <a:t> the </a:t>
+            </a:r>
+            <a:r>
+              <a:rPr lang="it-IT" sz="1900" dirty="0" err="1">
+                <a:solidFill>
+                  <a:srgbClr val="1D1D1D"/>
+                </a:solidFill>
+                <a:latin typeface="Aptos"/>
+              </a:rPr>
+              <a:t>same</a:t>
+            </a:r>
+            <a:r>
+              <a:rPr lang="it-IT" sz="1900" dirty="0">
+                <a:solidFill>
+                  <a:srgbClr val="1D1D1D"/>
+                </a:solidFill>
+                <a:latin typeface="Aptos"/>
+              </a:rPr>
+              <a:t> </a:t>
+            </a:r>
+            <a:r>
+              <a:rPr lang="it-IT" sz="1900" dirty="0" err="1">
+                <a:solidFill>
+                  <a:srgbClr val="1D1D1D"/>
+                </a:solidFill>
+                <a:latin typeface="Aptos"/>
+              </a:rPr>
+              <a:t>consolidated</a:t>
+            </a:r>
+            <a:r>
+              <a:rPr lang="it-IT" sz="1900" dirty="0">
+                <a:solidFill>
+                  <a:srgbClr val="1D1D1D"/>
+                </a:solidFill>
+                <a:latin typeface="Aptos"/>
+              </a:rPr>
+              <a:t> record to the </a:t>
+            </a:r>
+            <a:r>
+              <a:rPr lang="it-IT" sz="1900" dirty="0" err="1">
+                <a:solidFill>
+                  <a:srgbClr val="1D1D1D"/>
+                </a:solidFill>
+                <a:latin typeface="Aptos"/>
+              </a:rPr>
+              <a:t>frontend</a:t>
+            </a:r>
+            <a:r>
+              <a:rPr lang="it-IT" sz="1900" dirty="0">
+                <a:solidFill>
+                  <a:srgbClr val="1D1D1D"/>
+                </a:solidFill>
+                <a:latin typeface="Aptos"/>
+              </a:rPr>
+              <a:t>.</a:t>
             </a:r>
           </a:p>
         </p:txBody>
@@ -10165,7 +10900,7 @@
         </p:nvSpPr>
         <p:spPr>
           <a:xfrm>
-            <a:off x="6748272" y="3285652"/>
+            <a:off x="6748270" y="3188674"/>
             <a:ext cx="3694176" cy="274320"/>
           </a:xfrm>
           <a:prstGeom prst="rect">
@@ -10180,7 +10915,7 @@
           <a:lstStyle/>
           <a:p>
             <a:r>
-              <a:rPr sz="1300" b="1">
+              <a:rPr sz="1300" b="1" dirty="0">
                 <a:solidFill>
                   <a:srgbClr val="24303B"/>
                 </a:solidFill>
@@ -10199,8 +10934,8 @@
         </p:nvSpPr>
         <p:spPr>
           <a:xfrm>
-            <a:off x="6748270" y="3529584"/>
-            <a:ext cx="3694176" cy="523220"/>
+            <a:off x="6665973" y="3459892"/>
+            <a:ext cx="3858770" cy="523220"/>
           </a:xfrm>
           <a:prstGeom prst="rect">
             <a:avLst/>
@@ -10214,13 +10949,67 @@
           <a:lstStyle/>
           <a:p>
             <a:r>
-              <a:rPr sz="1400" i="1" dirty="0" err="1">
-                <a:solidFill>
-                  <a:srgbClr val="1D1D1D"/>
-                </a:solidFill>
-                <a:latin typeface="Aptos"/>
-              </a:rPr>
-              <a:t>Single writer to PostgreSQL and single live feed for the dashboard.</a:t>
+              <a:rPr lang="it-IT" sz="1400" i="1" dirty="0">
+                <a:solidFill>
+                  <a:srgbClr val="1D1D1D"/>
+                </a:solidFill>
+                <a:latin typeface="Aptos"/>
+              </a:rPr>
+              <a:t>Single </a:t>
+            </a:r>
+            <a:r>
+              <a:rPr lang="it-IT" sz="1400" i="1" dirty="0" err="1">
+                <a:solidFill>
+                  <a:srgbClr val="1D1D1D"/>
+                </a:solidFill>
+                <a:latin typeface="Aptos"/>
+              </a:rPr>
+              <a:t>ingestion</a:t>
+            </a:r>
+            <a:r>
+              <a:rPr lang="it-IT" sz="1400" i="1" dirty="0">
+                <a:solidFill>
+                  <a:srgbClr val="1D1D1D"/>
+                </a:solidFill>
+                <a:latin typeface="Aptos"/>
+              </a:rPr>
+              <a:t> point for </a:t>
+            </a:r>
+            <a:r>
+              <a:rPr lang="it-IT" sz="1400" i="1" dirty="0" err="1">
+                <a:solidFill>
+                  <a:srgbClr val="1D1D1D"/>
+                </a:solidFill>
+                <a:latin typeface="Aptos"/>
+              </a:rPr>
+              <a:t>replicas</a:t>
+            </a:r>
+            <a:r>
+              <a:rPr lang="it-IT" sz="1400" i="1" dirty="0">
+                <a:solidFill>
+                  <a:srgbClr val="1D1D1D"/>
+                </a:solidFill>
+                <a:latin typeface="Aptos"/>
+              </a:rPr>
+              <a:t>, writer to </a:t>
+            </a:r>
+            <a:r>
+              <a:rPr lang="it-IT" sz="1400" i="1" dirty="0" err="1">
+                <a:solidFill>
+                  <a:srgbClr val="1D1D1D"/>
+                </a:solidFill>
+                <a:latin typeface="Aptos"/>
+              </a:rPr>
+              <a:t>PostgreSQL</a:t>
+            </a:r>
+            <a:r>
+              <a:rPr lang="it-IT" sz="1400" i="1" dirty="0">
+                <a:solidFill>
+                  <a:srgbClr val="1D1D1D"/>
+                </a:solidFill>
+                <a:latin typeface="Aptos"/>
+              </a:rPr>
+              <a:t>, and live source for the dashboard.</a:t>
             </a:r>
             <a:endParaRPr sz="1400" dirty="0">
               <a:solidFill>
@@ -10436,7 +11225,7 @@
           <a:lstStyle/>
           <a:p>
             <a:r>
-              <a:rPr sz="900">
+              <a:rPr sz="900" dirty="0">
                 <a:solidFill>
                   <a:srgbClr val="656056"/>
                 </a:solidFill>
@@ -10567,14 +11356,14 @@
       </p:grpSpPr>
       <p:sp>
         <p:nvSpPr>
-          <p:cNvPr id="2" name="TextBox 1"/>
+          <p:cNvPr id="3" name="TextBox 2"/>
           <p:cNvSpPr txBox="1"/>
           <p:nvPr/>
         </p:nvSpPr>
         <p:spPr>
           <a:xfrm>
-            <a:off x="640080" y="411480"/>
-            <a:ext cx="2743200" cy="228600"/>
+            <a:off x="548640" y="429768"/>
+            <a:ext cx="4948791" cy="523220"/>
           </a:xfrm>
           <a:prstGeom prst="rect">
             <a:avLst/>
@@ -10588,48 +11377,29 @@
           <a:lstStyle/>
           <a:p>
             <a:r>
-              <a:rPr sz="1000" b="1">
-                <a:solidFill>
-                  <a:srgbClr val="804A35"/>
-                </a:solidFill>
-                <a:latin typeface="Aptos"/>
-              </a:rPr>
-              <a:t>SINGLE ENTRY POINT</a:t>
-            </a:r>
-          </a:p>
-        </p:txBody>
-      </p:sp>
-      <p:sp>
-        <p:nvSpPr>
-          <p:cNvPr id="3" name="TextBox 2"/>
-          <p:cNvSpPr txBox="1"/>
-          <p:nvPr/>
-        </p:nvSpPr>
-        <p:spPr>
-          <a:xfrm>
-            <a:off x="640080" y="640080"/>
-            <a:ext cx="7955279" cy="731520"/>
-          </a:xfrm>
-          <a:prstGeom prst="rect">
-            <a:avLst/>
-          </a:prstGeom>
-          <a:noFill/>
-        </p:spPr>
-        <p:txBody>
-          <a:bodyPr wrap="none">
-            <a:spAutoFit/>
-          </a:bodyPr>
-          <a:lstStyle/>
-          <a:p>
-            <a:r>
-              <a:rPr sz="2800" b="0">
+              <a:rPr lang="it-IT" sz="2800" b="0" dirty="0" err="1">
                 <a:solidFill>
                   <a:srgbClr val="1D1D1D"/>
                 </a:solidFill>
                 <a:latin typeface="Georgia"/>
               </a:rPr>
-              <a:t>Gateway, Database and APIs</a:t>
-            </a:r>
+              <a:t>PostgreSQL</a:t>
+            </a:r>
+            <a:r>
+              <a:rPr lang="it-IT" sz="2800" b="0">
+                <a:solidFill>
+                  <a:srgbClr val="1D1D1D"/>
+                </a:solidFill>
+                <a:latin typeface="Georgia"/>
+              </a:rPr>
+              <a:t> Database Schema</a:t>
+            </a:r>
+            <a:endParaRPr sz="2800" b="0" dirty="0">
+              <a:solidFill>
+                <a:srgbClr val="1D1D1D"/>
+              </a:solidFill>
+              <a:latin typeface="Georgia"/>
+            </a:endParaRPr>
           </a:p>
         </p:txBody>
       </p:sp>
@@ -11506,6 +12276,56 @@
               </a:rPr>
               <a:t>14</a:t>
             </a:r>
+          </a:p>
+        </p:txBody>
+      </p:sp>
+      <p:sp>
+        <p:nvSpPr>
+          <p:cNvPr id="27" name="Rectangle 15">
+            <a:extLst>
+              <a:ext uri="{FF2B5EF4-FFF2-40B4-BE49-F238E27FC236}">
+                <a16:creationId xmlns:a16="http://schemas.microsoft.com/office/drawing/2014/main" id="{2E36BD8E-24DC-6F2D-565E-71D160C35D24}"/>
+              </a:ext>
+            </a:extLst>
+          </p:cNvPr>
+          <p:cNvSpPr/>
+          <p:nvPr/>
+        </p:nvSpPr>
+        <p:spPr>
+          <a:xfrm>
+            <a:off x="250373" y="222782"/>
+            <a:ext cx="66542" cy="1082235"/>
+          </a:xfrm>
+          <a:prstGeom prst="rect">
+            <a:avLst/>
+          </a:prstGeom>
+          <a:solidFill>
+            <a:srgbClr val="804A35"/>
+          </a:solidFill>
+          <a:ln>
+            <a:noFill/>
+          </a:ln>
+        </p:spPr>
+        <p:style>
+          <a:lnRef idx="1">
+            <a:schemeClr val="accent1"/>
+          </a:lnRef>
+          <a:fillRef idx="3">
+            <a:schemeClr val="accent1"/>
+          </a:fillRef>
+          <a:effectRef idx="2">
+            <a:schemeClr val="accent1"/>
+          </a:effectRef>
+          <a:fontRef idx="minor">
+            <a:schemeClr val="lt1"/>
+          </a:fontRef>
+        </p:style>
+        <p:txBody>
+          <a:bodyPr rtlCol="0" anchor="ctr"/>
+          <a:lstStyle/>
+          <a:p>
+            <a:pPr algn="ctr"/>
+            <a:endParaRPr/>
           </a:p>
         </p:txBody>
       </p:sp>
@@ -11544,47 +12364,13 @@
       </p:grpSpPr>
       <p:sp>
         <p:nvSpPr>
-          <p:cNvPr id="2" name="TextBox 1"/>
-          <p:cNvSpPr txBox="1"/>
-          <p:nvPr/>
-        </p:nvSpPr>
-        <p:spPr>
-          <a:xfrm>
-            <a:off x="640080" y="411480"/>
-            <a:ext cx="2743200" cy="228600"/>
-          </a:xfrm>
-          <a:prstGeom prst="rect">
-            <a:avLst/>
-          </a:prstGeom>
-          <a:noFill/>
-        </p:spPr>
-        <p:txBody>
-          <a:bodyPr wrap="none">
-            <a:spAutoFit/>
-          </a:bodyPr>
-          <a:lstStyle/>
-          <a:p>
-            <a:r>
-              <a:rPr sz="1000" b="1">
-                <a:solidFill>
-                  <a:srgbClr val="804A35"/>
-                </a:solidFill>
-                <a:latin typeface="Aptos"/>
-              </a:rPr>
-              <a:t>FRONTEND MOCKUP</a:t>
-            </a:r>
-          </a:p>
-        </p:txBody>
-      </p:sp>
-      <p:sp>
-        <p:nvSpPr>
           <p:cNvPr id="3" name="TextBox 2"/>
           <p:cNvSpPr txBox="1"/>
           <p:nvPr/>
         </p:nvSpPr>
         <p:spPr>
           <a:xfrm>
-            <a:off x="640080" y="640080"/>
+            <a:off x="417658" y="458132"/>
             <a:ext cx="2422458" cy="523220"/>
           </a:xfrm>
           <a:prstGeom prst="rect">
@@ -11650,8 +12436,8 @@
         </p:blipFill>
         <p:spPr>
           <a:xfrm>
-            <a:off x="1228804" y="1634495"/>
-            <a:ext cx="9105169" cy="4581898"/>
+            <a:off x="2940859" y="962333"/>
+            <a:ext cx="8548734" cy="5286727"/>
           </a:xfrm>
           <a:prstGeom prst="rect">
             <a:avLst/>
@@ -11768,6 +12554,56 @@
               </a:rPr>
               <a:t>15</a:t>
             </a:r>
+          </a:p>
+        </p:txBody>
+      </p:sp>
+      <p:sp>
+        <p:nvSpPr>
+          <p:cNvPr id="5" name="Rectangle 15">
+            <a:extLst>
+              <a:ext uri="{FF2B5EF4-FFF2-40B4-BE49-F238E27FC236}">
+                <a16:creationId xmlns:a16="http://schemas.microsoft.com/office/drawing/2014/main" id="{94358AAB-D9DE-7895-18C8-0EF4AC51834B}"/>
+              </a:ext>
+            </a:extLst>
+          </p:cNvPr>
+          <p:cNvSpPr/>
+          <p:nvPr/>
+        </p:nvSpPr>
+        <p:spPr>
+          <a:xfrm>
+            <a:off x="250373" y="222782"/>
+            <a:ext cx="66542" cy="1082235"/>
+          </a:xfrm>
+          <a:prstGeom prst="rect">
+            <a:avLst/>
+          </a:prstGeom>
+          <a:solidFill>
+            <a:srgbClr val="804A35"/>
+          </a:solidFill>
+          <a:ln>
+            <a:noFill/>
+          </a:ln>
+        </p:spPr>
+        <p:style>
+          <a:lnRef idx="1">
+            <a:schemeClr val="accent1"/>
+          </a:lnRef>
+          <a:fillRef idx="3">
+            <a:schemeClr val="accent1"/>
+          </a:fillRef>
+          <a:effectRef idx="2">
+            <a:schemeClr val="accent1"/>
+          </a:effectRef>
+          <a:fontRef idx="minor">
+            <a:schemeClr val="lt1"/>
+          </a:fontRef>
+        </p:style>
+        <p:txBody>
+          <a:bodyPr rtlCol="0" anchor="ctr"/>
+          <a:lstStyle/>
+          <a:p>
+            <a:pPr algn="ctr"/>
+            <a:endParaRPr/>
           </a:p>
         </p:txBody>
       </p:sp>
@@ -11888,8 +12724,8 @@
         </p:blipFill>
         <p:spPr>
           <a:xfrm>
-            <a:off x="822960" y="1645920"/>
-            <a:ext cx="5074920" cy="3337560"/>
+            <a:off x="378036" y="1353312"/>
+            <a:ext cx="5519844" cy="3630168"/>
           </a:xfrm>
           <a:prstGeom prst="rect">
             <a:avLst/>
@@ -11912,8 +12748,8 @@
         </p:blipFill>
         <p:spPr>
           <a:xfrm>
-            <a:off x="6080760" y="1645920"/>
-            <a:ext cx="4983480" cy="3337560"/>
+            <a:off x="6080760" y="1353312"/>
+            <a:ext cx="5420388" cy="3630168"/>
           </a:xfrm>
           <a:prstGeom prst="rect">
             <a:avLst/>
@@ -11928,7 +12764,7 @@
         </p:nvSpPr>
         <p:spPr>
           <a:xfrm>
-            <a:off x="822960" y="5120640"/>
+            <a:off x="640080" y="5120640"/>
             <a:ext cx="5074920" cy="1097280"/>
           </a:xfrm>
           <a:prstGeom prst="roundRect">
@@ -11974,7 +12810,7 @@
         </p:nvSpPr>
         <p:spPr>
           <a:xfrm>
-            <a:off x="987552" y="5230368"/>
+            <a:off x="804672" y="5230368"/>
             <a:ext cx="4745736" cy="274320"/>
           </a:xfrm>
           <a:prstGeom prst="rect">
@@ -12008,7 +12844,7 @@
         </p:nvSpPr>
         <p:spPr>
           <a:xfrm>
-            <a:off x="987552" y="5500116"/>
+            <a:off x="804672" y="5500116"/>
             <a:ext cx="4745736" cy="201168"/>
           </a:xfrm>
           <a:prstGeom prst="rect">
@@ -12042,7 +12878,7 @@
         </p:nvSpPr>
         <p:spPr>
           <a:xfrm>
-            <a:off x="6080760" y="5120640"/>
+            <a:off x="6294122" y="5120640"/>
             <a:ext cx="4983480" cy="1097280"/>
           </a:xfrm>
           <a:prstGeom prst="roundRect">
@@ -12088,7 +12924,7 @@
         </p:nvSpPr>
         <p:spPr>
           <a:xfrm>
-            <a:off x="6245352" y="5230368"/>
+            <a:off x="6481573" y="5221471"/>
             <a:ext cx="4654296" cy="274320"/>
           </a:xfrm>
           <a:prstGeom prst="rect">
@@ -12122,7 +12958,7 @@
         </p:nvSpPr>
         <p:spPr>
           <a:xfrm>
-            <a:off x="6245352" y="5443874"/>
+            <a:off x="6458714" y="5459215"/>
             <a:ext cx="4654296" cy="738664"/>
           </a:xfrm>
           <a:prstGeom prst="rect">
@@ -19109,7 +19945,7 @@
         <p:spPr>
           <a:xfrm>
             <a:off x="418138" y="483059"/>
-            <a:ext cx="7955279" cy="731520"/>
+            <a:ext cx="4969630" cy="523220"/>
           </a:xfrm>
           <a:prstGeom prst="rect">
             <a:avLst/>
@@ -19123,14 +19959,38 @@
           <a:lstStyle/>
           <a:p>
             <a:r>
-              <a:rPr sz="2800" b="0" dirty="0">
+              <a:rPr lang="it-IT" sz="2800" b="0" dirty="0">
                 <a:solidFill>
                   <a:srgbClr val="1D1D1D"/>
                 </a:solidFill>
                 <a:latin typeface="Georgia"/>
               </a:rPr>
-              <a:t>End-to-End Integration Flow</a:t>
-            </a:r>
+              <a:t>Broker </a:t>
+            </a:r>
+            <a:r>
+              <a:rPr lang="it-IT" sz="2800" b="0" dirty="0" err="1">
+                <a:solidFill>
+                  <a:srgbClr val="1D1D1D"/>
+                </a:solidFill>
+                <a:latin typeface="Georgia"/>
+              </a:rPr>
+              <a:t>Ingestion</a:t>
+            </a:r>
+            <a:r>
+              <a:rPr lang="it-IT" sz="2800" b="0" dirty="0">
+                <a:solidFill>
+                  <a:srgbClr val="1D1D1D"/>
+                </a:solidFill>
+                <a:latin typeface="Georgia"/>
+              </a:rPr>
+              <a:t> and Fan-Out</a:t>
+            </a:r>
+            <a:endParaRPr sz="2800" b="0" dirty="0">
+              <a:solidFill>
+                <a:srgbClr val="1D1D1D"/>
+              </a:solidFill>
+              <a:latin typeface="Georgia"/>
+            </a:endParaRPr>
           </a:p>
         </p:txBody>
       </p:sp>
@@ -19223,7 +20083,7 @@
         <p:spPr>
           <a:xfrm>
             <a:off x="777239" y="3227045"/>
-            <a:ext cx="2139696" cy="704088"/>
+            <a:ext cx="2139696" cy="954107"/>
           </a:xfrm>
           <a:prstGeom prst="rect">
             <a:avLst/>
@@ -19237,14 +20097,92 @@
           <a:lstStyle/>
           <a:p>
             <a:r>
-              <a:rPr sz="1400">
-                <a:solidFill>
-                  <a:srgbClr val="1D1D1D"/>
-                </a:solidFill>
-                <a:latin typeface="Aptos"/>
-              </a:rPr>
-              <a:t>Broker normalizes simulator samples and broadcasts the same measurement envelope to every replica.</a:t>
-            </a:r>
+              <a:rPr lang="it-IT" sz="1400" dirty="0">
+                <a:solidFill>
+                  <a:srgbClr val="1D1D1D"/>
+                </a:solidFill>
+                <a:latin typeface="Aptos"/>
+              </a:rPr>
+              <a:t>The broker </a:t>
+            </a:r>
+            <a:r>
+              <a:rPr lang="it-IT" sz="1400" dirty="0" err="1">
+                <a:solidFill>
+                  <a:srgbClr val="1D1D1D"/>
+                </a:solidFill>
+                <a:latin typeface="Aptos"/>
+              </a:rPr>
+              <a:t>discovers</a:t>
+            </a:r>
+            <a:r>
+              <a:rPr lang="it-IT" sz="1400" dirty="0">
+                <a:solidFill>
+                  <a:srgbClr val="1D1D1D"/>
+                </a:solidFill>
+                <a:latin typeface="Aptos"/>
+              </a:rPr>
+              <a:t> </a:t>
+            </a:r>
+            <a:r>
+              <a:rPr lang="it-IT" sz="1400" dirty="0" err="1">
+                <a:solidFill>
+                  <a:srgbClr val="1D1D1D"/>
+                </a:solidFill>
+                <a:latin typeface="Aptos"/>
+              </a:rPr>
+              <a:t>available</a:t>
+            </a:r>
+            <a:r>
+              <a:rPr lang="it-IT" sz="1400" dirty="0">
+                <a:solidFill>
+                  <a:srgbClr val="1D1D1D"/>
+                </a:solidFill>
+                <a:latin typeface="Aptos"/>
+              </a:rPr>
+              <a:t> </a:t>
+            </a:r>
+            <a:r>
+              <a:rPr lang="it-IT" sz="1400" dirty="0" err="1">
+                <a:solidFill>
+                  <a:srgbClr val="1D1D1D"/>
+                </a:solidFill>
+                <a:latin typeface="Aptos"/>
+              </a:rPr>
+              <a:t>sensors</a:t>
+            </a:r>
+            <a:r>
+              <a:rPr lang="it-IT" sz="1400" dirty="0">
+                <a:solidFill>
+                  <a:srgbClr val="1D1D1D"/>
+                </a:solidFill>
+                <a:latin typeface="Aptos"/>
+              </a:rPr>
+              <a:t> from the simulator </a:t>
+            </a:r>
+            <a:r>
+              <a:rPr lang="it-IT" sz="1400" dirty="0" err="1">
+                <a:solidFill>
+                  <a:srgbClr val="1D1D1D"/>
+                </a:solidFill>
+                <a:latin typeface="Aptos"/>
+              </a:rPr>
+              <a:t>through</a:t>
+            </a:r>
+            <a:r>
+              <a:rPr lang="it-IT" sz="1400" dirty="0">
+                <a:solidFill>
+                  <a:srgbClr val="1D1D1D"/>
+                </a:solidFill>
+                <a:latin typeface="Aptos"/>
+              </a:rPr>
+              <a:t> GET /api/devices/</a:t>
+            </a:r>
+            <a:endParaRPr sz="1400" dirty="0">
+              <a:solidFill>
+                <a:srgbClr val="1D1D1D"/>
+              </a:solidFill>
+              <a:latin typeface="Aptos"/>
+            </a:endParaRPr>
           </a:p>
         </p:txBody>
       </p:sp>
@@ -19381,7 +20319,7 @@
         <p:spPr>
           <a:xfrm>
             <a:off x="3623309" y="3223014"/>
-            <a:ext cx="2139696" cy="704088"/>
+            <a:ext cx="2139696" cy="1169551"/>
           </a:xfrm>
           <a:prstGeom prst="rect">
             <a:avLst/>
@@ -19395,14 +20333,173 @@
           <a:lstStyle/>
           <a:p>
             <a:r>
-              <a:rPr sz="1400" dirty="0">
-                <a:solidFill>
-                  <a:srgbClr val="1D1D1D"/>
-                </a:solidFill>
-                <a:latin typeface="Aptos"/>
-              </a:rPr>
-              <a:t>Each replica keeps independent sensor windows, runs FFT analysis, and classifies suspicious activity autonomously.</a:t>
-            </a:r>
+              <a:rPr lang="it-IT" sz="1400" dirty="0" err="1">
+                <a:solidFill>
+                  <a:srgbClr val="1D1D1D"/>
+                </a:solidFill>
+                <a:latin typeface="Aptos"/>
+              </a:rPr>
+              <a:t>It</a:t>
+            </a:r>
+            <a:r>
+              <a:rPr lang="it-IT" sz="1400" dirty="0">
+                <a:solidFill>
+                  <a:srgbClr val="1D1D1D"/>
+                </a:solidFill>
+                <a:latin typeface="Aptos"/>
+              </a:rPr>
+              <a:t> </a:t>
+            </a:r>
+            <a:r>
+              <a:rPr lang="it-IT" sz="1400" dirty="0" err="1">
+                <a:solidFill>
+                  <a:srgbClr val="1D1D1D"/>
+                </a:solidFill>
+                <a:latin typeface="Aptos"/>
+              </a:rPr>
+              <a:t>opens</a:t>
+            </a:r>
+            <a:r>
+              <a:rPr lang="it-IT" sz="1400" dirty="0">
+                <a:solidFill>
+                  <a:srgbClr val="1D1D1D"/>
+                </a:solidFill>
+                <a:latin typeface="Aptos"/>
+              </a:rPr>
+              <a:t> one upstream </a:t>
+            </a:r>
+            <a:r>
+              <a:rPr lang="it-IT" sz="1400" dirty="0" err="1">
+                <a:solidFill>
+                  <a:srgbClr val="1D1D1D"/>
+                </a:solidFill>
+                <a:latin typeface="Aptos"/>
+              </a:rPr>
+              <a:t>WebSocket</a:t>
+            </a:r>
+            <a:r>
+              <a:rPr lang="it-IT" sz="1400" dirty="0">
+                <a:solidFill>
+                  <a:srgbClr val="1D1D1D"/>
+                </a:solidFill>
+                <a:latin typeface="Aptos"/>
+              </a:rPr>
+              <a:t> stream for </a:t>
+            </a:r>
+            <a:r>
+              <a:rPr lang="it-IT" sz="1400" dirty="0" err="1">
+                <a:solidFill>
+                  <a:srgbClr val="1D1D1D"/>
+                </a:solidFill>
+                <a:latin typeface="Aptos"/>
+              </a:rPr>
+              <a:t>each</a:t>
+            </a:r>
+            <a:r>
+              <a:rPr lang="it-IT" sz="1400" dirty="0">
+                <a:solidFill>
+                  <a:srgbClr val="1D1D1D"/>
+                </a:solidFill>
+                <a:latin typeface="Aptos"/>
+              </a:rPr>
+              <a:t> </a:t>
+            </a:r>
+            <a:r>
+              <a:rPr lang="it-IT" sz="1400" dirty="0" err="1">
+                <a:solidFill>
+                  <a:srgbClr val="1D1D1D"/>
+                </a:solidFill>
+                <a:latin typeface="Aptos"/>
+              </a:rPr>
+              <a:t>sensor</a:t>
+            </a:r>
+            <a:r>
+              <a:rPr lang="it-IT" sz="1400" dirty="0">
+                <a:solidFill>
+                  <a:srgbClr val="1D1D1D"/>
+                </a:solidFill>
+                <a:latin typeface="Aptos"/>
+              </a:rPr>
+              <a:t> and </a:t>
+            </a:r>
+            <a:r>
+              <a:rPr lang="it-IT" sz="1400" dirty="0" err="1">
+                <a:solidFill>
+                  <a:srgbClr val="1D1D1D"/>
+                </a:solidFill>
+                <a:latin typeface="Aptos"/>
+              </a:rPr>
+              <a:t>continuously</a:t>
+            </a:r>
+            <a:r>
+              <a:rPr lang="it-IT" sz="1400" dirty="0">
+                <a:solidFill>
+                  <a:srgbClr val="1D1D1D"/>
+                </a:solidFill>
+                <a:latin typeface="Aptos"/>
+              </a:rPr>
+              <a:t> </a:t>
+            </a:r>
+            <a:r>
+              <a:rPr lang="it-IT" sz="1400" dirty="0" err="1">
+                <a:solidFill>
+                  <a:srgbClr val="1D1D1D"/>
+                </a:solidFill>
+                <a:latin typeface="Aptos"/>
+              </a:rPr>
+              <a:t>receives</a:t>
+            </a:r>
+            <a:r>
+              <a:rPr lang="it-IT" sz="1400" dirty="0">
+                <a:solidFill>
+                  <a:srgbClr val="1D1D1D"/>
+                </a:solidFill>
+                <a:latin typeface="Aptos"/>
+              </a:rPr>
+              <a:t> </a:t>
+            </a:r>
+            <a:r>
+              <a:rPr lang="it-IT" sz="1400" dirty="0" err="1">
+                <a:solidFill>
+                  <a:srgbClr val="1D1D1D"/>
+                </a:solidFill>
+                <a:latin typeface="Aptos"/>
+              </a:rPr>
+              <a:t>raw</a:t>
+            </a:r>
+            <a:r>
+              <a:rPr lang="it-IT" sz="1400" dirty="0">
+                <a:solidFill>
+                  <a:srgbClr val="1D1D1D"/>
+                </a:solidFill>
+                <a:latin typeface="Aptos"/>
+              </a:rPr>
+              <a:t> </a:t>
+            </a:r>
+            <a:r>
+              <a:rPr lang="it-IT" sz="1400" dirty="0" err="1">
+                <a:solidFill>
+                  <a:srgbClr val="1D1D1D"/>
+                </a:solidFill>
+                <a:latin typeface="Aptos"/>
+              </a:rPr>
+              <a:t>seismic</a:t>
+            </a:r>
+            <a:r>
+              <a:rPr lang="it-IT" sz="1400" dirty="0">
+                <a:solidFill>
+                  <a:srgbClr val="1D1D1D"/>
+                </a:solidFill>
+                <a:latin typeface="Aptos"/>
+              </a:rPr>
+              <a:t> samples.</a:t>
+            </a:r>
+            <a:endParaRPr sz="1400" dirty="0">
+              <a:solidFill>
+                <a:srgbClr val="1D1D1D"/>
+              </a:solidFill>
+              <a:latin typeface="Aptos"/>
+            </a:endParaRPr>
           </a:p>
         </p:txBody>
       </p:sp>
@@ -19538,8 +20635,8 @@
         </p:nvSpPr>
         <p:spPr>
           <a:xfrm>
-            <a:off x="6366510" y="3224587"/>
-            <a:ext cx="2139696" cy="704088"/>
+            <a:off x="6283379" y="3233271"/>
+            <a:ext cx="2304288" cy="1169551"/>
           </a:xfrm>
           <a:prstGeom prst="rect">
             <a:avLst/>
@@ -19553,14 +20650,191 @@
           <a:lstStyle/>
           <a:p>
             <a:r>
-              <a:rPr sz="1400">
-                <a:solidFill>
-                  <a:srgbClr val="1D1D1D"/>
-                </a:solidFill>
-                <a:latin typeface="Aptos"/>
-              </a:rPr>
-              <a:t>Replicas submit sensor metadata and detected events to the gateway through dedicated ingestion APIs.</a:t>
-            </a:r>
+              <a:rPr lang="it-IT" sz="1400" dirty="0" err="1">
+                <a:solidFill>
+                  <a:srgbClr val="1D1D1D"/>
+                </a:solidFill>
+                <a:latin typeface="Aptos"/>
+              </a:rPr>
+              <a:t>Each</a:t>
+            </a:r>
+            <a:r>
+              <a:rPr lang="it-IT" sz="1400" dirty="0">
+                <a:solidFill>
+                  <a:srgbClr val="1D1D1D"/>
+                </a:solidFill>
+                <a:latin typeface="Aptos"/>
+              </a:rPr>
+              <a:t> sample </a:t>
+            </a:r>
+            <a:r>
+              <a:rPr lang="it-IT" sz="1400" dirty="0" err="1">
+                <a:solidFill>
+                  <a:srgbClr val="1D1D1D"/>
+                </a:solidFill>
+                <a:latin typeface="Aptos"/>
+              </a:rPr>
+              <a:t>is</a:t>
+            </a:r>
+            <a:r>
+              <a:rPr lang="it-IT" sz="1400" dirty="0">
+                <a:solidFill>
+                  <a:srgbClr val="1D1D1D"/>
+                </a:solidFill>
+                <a:latin typeface="Aptos"/>
+              </a:rPr>
+              <a:t> </a:t>
+            </a:r>
+            <a:r>
+              <a:rPr lang="it-IT" sz="1400" dirty="0" err="1">
+                <a:solidFill>
+                  <a:srgbClr val="1D1D1D"/>
+                </a:solidFill>
+                <a:latin typeface="Aptos"/>
+              </a:rPr>
+              <a:t>normalized</a:t>
+            </a:r>
+            <a:r>
+              <a:rPr lang="it-IT" sz="1400" dirty="0">
+                <a:solidFill>
+                  <a:srgbClr val="1D1D1D"/>
+                </a:solidFill>
+                <a:latin typeface="Aptos"/>
+              </a:rPr>
+              <a:t> </a:t>
+            </a:r>
+            <a:r>
+              <a:rPr lang="it-IT" sz="1400" dirty="0" err="1">
+                <a:solidFill>
+                  <a:srgbClr val="1D1D1D"/>
+                </a:solidFill>
+                <a:latin typeface="Aptos"/>
+              </a:rPr>
+              <a:t>into</a:t>
+            </a:r>
+            <a:r>
+              <a:rPr lang="it-IT" sz="1400" dirty="0">
+                <a:solidFill>
+                  <a:srgbClr val="1D1D1D"/>
+                </a:solidFill>
+                <a:latin typeface="Aptos"/>
+              </a:rPr>
+              <a:t> a </a:t>
+            </a:r>
+            <a:r>
+              <a:rPr lang="it-IT" sz="1400" dirty="0" err="1">
+                <a:solidFill>
+                  <a:srgbClr val="1D1D1D"/>
+                </a:solidFill>
+                <a:latin typeface="Aptos"/>
+              </a:rPr>
+              <a:t>shared</a:t>
+            </a:r>
+            <a:r>
+              <a:rPr lang="it-IT" sz="1400" dirty="0">
+                <a:solidFill>
+                  <a:srgbClr val="1D1D1D"/>
+                </a:solidFill>
+                <a:latin typeface="Aptos"/>
+              </a:rPr>
+              <a:t> </a:t>
+            </a:r>
+            <a:r>
+              <a:rPr lang="it-IT" sz="1400" dirty="0" err="1">
+                <a:solidFill>
+                  <a:srgbClr val="1D1D1D"/>
+                </a:solidFill>
+                <a:latin typeface="Aptos"/>
+              </a:rPr>
+              <a:t>measurement</a:t>
+            </a:r>
+            <a:r>
+              <a:rPr lang="it-IT" sz="1400" dirty="0">
+                <a:solidFill>
+                  <a:srgbClr val="1D1D1D"/>
+                </a:solidFill>
+                <a:latin typeface="Aptos"/>
+              </a:rPr>
+              <a:t> </a:t>
+            </a:r>
+            <a:r>
+              <a:rPr lang="it-IT" sz="1400" dirty="0" err="1">
+                <a:solidFill>
+                  <a:srgbClr val="1D1D1D"/>
+                </a:solidFill>
+                <a:latin typeface="Aptos"/>
+              </a:rPr>
+              <a:t>envelope</a:t>
+            </a:r>
+            <a:r>
+              <a:rPr lang="it-IT" sz="1400" dirty="0">
+                <a:solidFill>
+                  <a:srgbClr val="1D1D1D"/>
+                </a:solidFill>
+                <a:latin typeface="Aptos"/>
+              </a:rPr>
+              <a:t> </a:t>
+            </a:r>
+            <a:r>
+              <a:rPr lang="it-IT" sz="1400" dirty="0" err="1">
+                <a:solidFill>
+                  <a:srgbClr val="1D1D1D"/>
+                </a:solidFill>
+                <a:latin typeface="Aptos"/>
+              </a:rPr>
+              <a:t>enriched</a:t>
+            </a:r>
+            <a:r>
+              <a:rPr lang="it-IT" sz="1400" dirty="0">
+                <a:solidFill>
+                  <a:srgbClr val="1D1D1D"/>
+                </a:solidFill>
+                <a:latin typeface="Aptos"/>
+              </a:rPr>
+              <a:t> with </a:t>
+            </a:r>
+            <a:r>
+              <a:rPr lang="it-IT" sz="1400" dirty="0" err="1">
+                <a:solidFill>
+                  <a:srgbClr val="1D1D1D"/>
+                </a:solidFill>
+                <a:latin typeface="Aptos"/>
+              </a:rPr>
+              <a:t>sensor</a:t>
+            </a:r>
+            <a:r>
+              <a:rPr lang="it-IT" sz="1400" dirty="0">
+                <a:solidFill>
+                  <a:srgbClr val="1D1D1D"/>
+                </a:solidFill>
+                <a:latin typeface="Aptos"/>
+              </a:rPr>
+              <a:t> metadata and </a:t>
+            </a:r>
+            <a:r>
+              <a:rPr lang="it-IT" sz="1400" dirty="0" err="1">
+                <a:solidFill>
+                  <a:srgbClr val="1D1D1D"/>
+                </a:solidFill>
+                <a:latin typeface="Aptos"/>
+              </a:rPr>
+              <a:t>timestamps</a:t>
+            </a:r>
+            <a:r>
+              <a:rPr lang="it-IT" sz="1400" dirty="0">
+                <a:solidFill>
+                  <a:srgbClr val="1D1D1D"/>
+                </a:solidFill>
+                <a:latin typeface="Aptos"/>
+              </a:rPr>
+              <a:t>.</a:t>
+            </a:r>
+            <a:endParaRPr sz="1400" dirty="0">
+              <a:solidFill>
+                <a:srgbClr val="1D1D1D"/>
+              </a:solidFill>
+              <a:latin typeface="Aptos"/>
+            </a:endParaRPr>
           </a:p>
         </p:txBody>
       </p:sp>
@@ -19697,7 +20971,7 @@
         <p:spPr>
           <a:xfrm>
             <a:off x="9120083" y="3224587"/>
-            <a:ext cx="2139696" cy="704088"/>
+            <a:ext cx="2139696" cy="1169551"/>
           </a:xfrm>
           <a:prstGeom prst="rect">
             <a:avLst/>
@@ -19711,14 +20985,164 @@
           <a:lstStyle/>
           <a:p>
             <a:r>
-              <a:rPr sz="1400">
-                <a:solidFill>
-                  <a:srgbClr val="1D1D1D"/>
-                </a:solidFill>
-                <a:latin typeface="Aptos"/>
-              </a:rPr>
-              <a:t>The gateway deduplicates, persists to PostgreSQL, and serves aligned live and historical data to the frontend.</a:t>
-            </a:r>
+              <a:rPr lang="it-IT" sz="1400" dirty="0">
+                <a:solidFill>
+                  <a:srgbClr val="1D1D1D"/>
+                </a:solidFill>
+                <a:latin typeface="Aptos"/>
+              </a:rPr>
+              <a:t>The broker </a:t>
+            </a:r>
+            <a:r>
+              <a:rPr lang="it-IT" sz="1400" dirty="0" err="1">
+                <a:solidFill>
+                  <a:srgbClr val="1D1D1D"/>
+                </a:solidFill>
+                <a:latin typeface="Aptos"/>
+              </a:rPr>
+              <a:t>broadcasts</a:t>
+            </a:r>
+            <a:r>
+              <a:rPr lang="it-IT" sz="1400" dirty="0">
+                <a:solidFill>
+                  <a:srgbClr val="1D1D1D"/>
+                </a:solidFill>
+                <a:latin typeface="Aptos"/>
+              </a:rPr>
+              <a:t> the </a:t>
+            </a:r>
+            <a:r>
+              <a:rPr lang="it-IT" sz="1400" dirty="0" err="1">
+                <a:solidFill>
+                  <a:srgbClr val="1D1D1D"/>
+                </a:solidFill>
+                <a:latin typeface="Aptos"/>
+              </a:rPr>
+              <a:t>same</a:t>
+            </a:r>
+            <a:r>
+              <a:rPr lang="it-IT" sz="1400" dirty="0">
+                <a:solidFill>
+                  <a:srgbClr val="1D1D1D"/>
+                </a:solidFill>
+                <a:latin typeface="Aptos"/>
+              </a:rPr>
+              <a:t> </a:t>
+            </a:r>
+            <a:r>
+              <a:rPr lang="it-IT" sz="1400" dirty="0" err="1">
+                <a:solidFill>
+                  <a:srgbClr val="1D1D1D"/>
+                </a:solidFill>
+                <a:latin typeface="Aptos"/>
+              </a:rPr>
+              <a:t>envelope</a:t>
+            </a:r>
+            <a:r>
+              <a:rPr lang="it-IT" sz="1400" dirty="0">
+                <a:solidFill>
+                  <a:srgbClr val="1D1D1D"/>
+                </a:solidFill>
+                <a:latin typeface="Aptos"/>
+              </a:rPr>
+              <a:t> to </a:t>
+            </a:r>
+            <a:r>
+              <a:rPr lang="it-IT" sz="1400" dirty="0" err="1">
+                <a:solidFill>
+                  <a:srgbClr val="1D1D1D"/>
+                </a:solidFill>
+                <a:latin typeface="Aptos"/>
+              </a:rPr>
+              <a:t>every</a:t>
+            </a:r>
+            <a:r>
+              <a:rPr lang="it-IT" sz="1400" dirty="0">
+                <a:solidFill>
+                  <a:srgbClr val="1D1D1D"/>
+                </a:solidFill>
+                <a:latin typeface="Aptos"/>
+              </a:rPr>
+              <a:t> </a:t>
+            </a:r>
+            <a:r>
+              <a:rPr lang="it-IT" sz="1400" dirty="0" err="1">
+                <a:solidFill>
+                  <a:srgbClr val="1D1D1D"/>
+                </a:solidFill>
+                <a:latin typeface="Aptos"/>
+              </a:rPr>
+              <a:t>connected</a:t>
+            </a:r>
+            <a:r>
+              <a:rPr lang="it-IT" sz="1400" dirty="0">
+                <a:solidFill>
+                  <a:srgbClr val="1D1D1D"/>
+                </a:solidFill>
+                <a:latin typeface="Aptos"/>
+              </a:rPr>
+              <a:t> replica, </a:t>
+            </a:r>
+            <a:r>
+              <a:rPr lang="it-IT" sz="1400" dirty="0" err="1">
+                <a:solidFill>
+                  <a:srgbClr val="1D1D1D"/>
+                </a:solidFill>
+                <a:latin typeface="Aptos"/>
+              </a:rPr>
+              <a:t>enabling</a:t>
+            </a:r>
+            <a:r>
+              <a:rPr lang="it-IT" sz="1400" dirty="0">
+                <a:solidFill>
+                  <a:srgbClr val="1D1D1D"/>
+                </a:solidFill>
+                <a:latin typeface="Aptos"/>
+              </a:rPr>
+              <a:t> </a:t>
+            </a:r>
+            <a:r>
+              <a:rPr lang="it-IT" sz="1400" dirty="0" err="1">
+                <a:solidFill>
+                  <a:srgbClr val="1D1D1D"/>
+                </a:solidFill>
+                <a:latin typeface="Aptos"/>
+              </a:rPr>
+              <a:t>parallel</a:t>
+            </a:r>
+            <a:r>
+              <a:rPr lang="it-IT" sz="1400" dirty="0">
+                <a:solidFill>
+                  <a:srgbClr val="1D1D1D"/>
+                </a:solidFill>
+                <a:latin typeface="Aptos"/>
+              </a:rPr>
+              <a:t> fault-</a:t>
+            </a:r>
+            <a:r>
+              <a:rPr lang="it-IT" sz="1400" dirty="0" err="1">
+                <a:solidFill>
+                  <a:srgbClr val="1D1D1D"/>
+                </a:solidFill>
+                <a:latin typeface="Aptos"/>
+              </a:rPr>
+              <a:t>tolerant</a:t>
+            </a:r>
+            <a:r>
+              <a:rPr lang="it-IT" sz="1400" dirty="0">
+                <a:solidFill>
+                  <a:srgbClr val="1D1D1D"/>
+                </a:solidFill>
+                <a:latin typeface="Aptos"/>
+              </a:rPr>
+              <a:t> processing.</a:t>
+            </a:r>
+            <a:endParaRPr sz="1400" dirty="0">
+              <a:solidFill>
+                <a:srgbClr val="1D1D1D"/>
+              </a:solidFill>
+              <a:latin typeface="Aptos"/>
+            </a:endParaRPr>
           </a:p>
         </p:txBody>
       </p:sp>

</xml_diff>